<commit_message>
Feat: Add last_string_device level in layout, correlated tuning
</commit_message>
<xml_diff>
--- a/docs/source/_static/oriom diagrams.pptx
+++ b/docs/source/_static/oriom diagrams.pptx
@@ -3116,7 +3116,7 @@
         </p:nvGrpSpPr>
         <p:grpSpPr>
           <a:xfrm>
-            <a:off x="2692007" y="418712"/>
+            <a:off x="2675544" y="401118"/>
             <a:ext cx="9162536" cy="6107083"/>
             <a:chOff x="2692007" y="418712"/>
             <a:chExt cx="9162536" cy="6107083"/>
@@ -4268,9 +4268,9 @@
                 <p:nvPr/>
               </p:nvCxnSpPr>
               <p:spPr>
-                <a:xfrm rot="16200000" flipH="1">
-                  <a:off x="3733913" y="2787080"/>
-                  <a:ext cx="440757" cy="18763"/>
+                <a:xfrm rot="5400000">
+                  <a:off x="3708831" y="2780760"/>
+                  <a:ext cx="440757" cy="31405"/>
                 </a:xfrm>
                 <a:prstGeom prst="bentConnector3">
                   <a:avLst>
@@ -4313,8 +4313,8 @@
               </p:nvSpPr>
               <p:spPr>
                 <a:xfrm>
-                  <a:off x="2259616" y="3016840"/>
-                  <a:ext cx="3408116" cy="221036"/>
+                  <a:off x="2209448" y="3016840"/>
+                  <a:ext cx="3408116" cy="221035"/>
                 </a:xfrm>
                 <a:prstGeom prst="roundRect">
                   <a:avLst/>
@@ -4380,14 +4380,14 @@
                 <p:nvPr/>
               </p:nvCxnSpPr>
               <p:spPr>
-                <a:xfrm rot="5400000" flipH="1">
-                  <a:off x="3512878" y="2787080"/>
-                  <a:ext cx="882828" cy="18763"/>
+                <a:xfrm rot="5400000" flipH="1" flipV="1">
+                  <a:off x="3487793" y="2780758"/>
+                  <a:ext cx="882828" cy="31405"/>
                 </a:xfrm>
                 <a:prstGeom prst="bentConnector5">
                   <a:avLst>
                     <a:gd name="adj1" fmla="val -33017"/>
-                    <a:gd name="adj2" fmla="val -9667560"/>
+                    <a:gd name="adj2" fmla="val 5985470"/>
                     <a:gd name="adj3" fmla="val 133017"/>
                   </a:avLst>
                 </a:prstGeom>
@@ -4822,14 +4822,13 @@
             </p:cNvPr>
             <p:cNvCxnSpPr>
               <a:cxnSpLocks/>
-              <a:endCxn id="138" idx="0"/>
             </p:cNvCxnSpPr>
             <p:nvPr/>
           </p:nvCxnSpPr>
           <p:spPr>
             <a:xfrm rot="16200000" flipH="1">
-              <a:off x="3518016" y="2028156"/>
-              <a:ext cx="299875" cy="1"/>
+              <a:off x="3206271" y="2332144"/>
+              <a:ext cx="864023" cy="2"/>
             </a:xfrm>
             <a:prstGeom prst="bentConnector3">
               <a:avLst>
@@ -5866,8 +5865,8 @@
         </p:nvSpPr>
         <p:spPr>
           <a:xfrm>
-            <a:off x="240365" y="241648"/>
-            <a:ext cx="2410854" cy="281878"/>
+            <a:off x="240365" y="241647"/>
+            <a:ext cx="1225578" cy="643723"/>
           </a:xfrm>
           <a:prstGeom prst="roundRect">
             <a:avLst/>
@@ -5901,20 +5900,12 @@
           <a:p>
             <a:pPr algn="ctr"/>
             <a:r>
-              <a:rPr lang="en-US" sz="1200" dirty="0" err="1">
-                <a:solidFill>
-                  <a:srgbClr val="000000"/>
-                </a:solidFill>
-              </a:rPr>
-              <a:t>MergecDeferred</a:t>
-            </a:r>
-            <a:r>
               <a:rPr lang="en-US" sz="1200" dirty="0">
                 <a:solidFill>
                   <a:srgbClr val="000000"/>
                 </a:solidFill>
               </a:rPr>
-              <a:t> TTP operations</a:t>
+              <a:t>Merge Deferred TTP operations</a:t>
             </a:r>
           </a:p>
         </p:txBody>

</xml_diff>